<commit_message>
feat(presentation): add dedicated ML pipeline leakage detection slide and update presentation deck
</commit_message>
<xml_diff>
--- a/AquaFlow_Project_Presentation.pptx
+++ b/AquaFlow_Project_Presentation.pptx
@@ -5963,7 +5963,7 @@
               </a:defRPr>
             </a:pPr>
             <a:r>
-              <a:t>•  Demographic Scaling</a:t>
+              <a:t>•  Demographic &amp; Cycle Normalization</a:t>
             </a:r>
           </a:p>
           <a:p>
@@ -5975,7 +5975,7 @@
               </a:defRPr>
             </a:pPr>
             <a:r>
-              <a:t>    Inputs include rolling 14-day history, day-of-week, household occupant count, and away status.</a:t>
+              <a:t>    Normalizes monthly kL into daily rates by cycle days (30/31d), factoring household size, BHK type, and away days.</a:t>
             </a:r>
           </a:p>
           <a:p>
@@ -5990,7 +5990,7 @@
               </a:defRPr>
             </a:pPr>
             <a:r>
-              <a:t>•  Human Reason Attribution</a:t>
+              <a:t>•  Continuous Risk Score &amp; Pattern Attribution</a:t>
             </a:r>
           </a:p>
           <a:p>
@@ -6002,7 +6002,7 @@
               </a:defRPr>
             </a:pPr>
             <a:r>
-              <a:t>    Classifies anomalies as CONTINUOUS_NIGHT_FLOW, ABNORMAL_SPIKE_FOR_HOUSEHOLD_SIZE, or UNEXPLAINED_AWAY_FLOW.</a:t>
+              <a:t>    Calculates 0–100% risk score and flags patterns: SUDDEN_SPIKE, GRADUAL_DRIFT, or AWAY_USAGE with explainable reasons.</a:t>
             </a:r>
           </a:p>
         </p:txBody>

</xml_diff>